<commit_message>
docs: Actualizar README, PPTX y MANUAL_USUARIO.md v6.0.0
README:
- Paleta azul corporativo (#2563eb)
- Tablas mejoradas (13 columnas, sort, filtro, cajas)
- Scripts de mantenimiento de catalogo
- Estructura actualizada

PPTX:
- Paleta azul corporativa
- Nuevos slides: Tabla mejorada, Paleta corporativa
- v6.0.0

MANUAL_USUARIO:
- Seccion 7.3: 13 columnas con Cajas, sort, filtro
- Nota: boton HTML unificado en sidebar

Limpieza:
- Eliminar scripts de diagnostico (analyze-html, calc-pedido, regen-report, verify-changes)
- Eliminar hook muerto useVendedor.js
- Eliminar archivos de prueba muertos (test_*.docx, skus-pedido.json)
- .gitignore: excluir archivos temporales
</commit_message>
<xml_diff>
--- a/docs/CIPSA_OrderX_Guia_Uso.pptx
+++ b/docs/CIPSA_OrderX_Guia_Uso.pptx
@@ -12,9 +12,12 @@
     <p:sldId id="260" r:id="rId6"/>
     <p:sldId id="261" r:id="rId7"/>
     <p:sldId id="262" r:id="rId8"/>
+    <p:sldId id="263" r:id="rId9"/>
+    <p:sldId id="264" r:id="rId10"/>
+    <p:sldId id="265" r:id="rId11"/>
   </p:sldIdLst>
   <p:notesMasterIdLst>
-    <p:notesMasterId r:id="rId9"/>
+    <p:notesMasterId r:id="rId12"/>
   </p:notesMasterIdLst>
   <p:sldSz cx="9144000" cy="5143500"/>
   <p:notesSz cx="5143500" cy="9144000"/>
@@ -550,6 +553,94 @@
 </p:notes>
 </file>
 
+<file path=ppt/notesSlides/notesSlide10.xml><?xml version="1.0" encoding="utf-8"?>
+<p:notes xmlns:a="http://schemas.openxmlformats.org/drawingml/2006/main" xmlns:r="http://schemas.openxmlformats.org/officeDocument/2006/relationships" xmlns:p="http://schemas.openxmlformats.org/presentationml/2006/main">
+  <p:cSld>
+    <p:spTree>
+      <p:nvGrpSpPr>
+        <p:cNvPr id="1" name=""/>
+        <p:cNvGrpSpPr/>
+        <p:nvPr/>
+      </p:nvGrpSpPr>
+      <p:grpSpPr>
+        <a:xfrm>
+          <a:off x="0" y="0"/>
+          <a:ext cx="0" cy="0"/>
+          <a:chOff x="0" y="0"/>
+          <a:chExt cx="0" cy="0"/>
+        </a:xfrm>
+      </p:grpSpPr>
+      <p:sp>
+        <p:nvSpPr>
+          <p:cNvPr id="2" name="Slide Image Placeholder 1"/>
+          <p:cNvSpPr>
+            <a:spLocks noGrp="1" noRot="1" noChangeAspect="1"/>
+          </p:cNvSpPr>
+          <p:nvPr>
+            <p:ph type="sldImg"/>
+          </p:nvPr>
+        </p:nvSpPr>
+        <p:spPr/>
+      </p:sp>
+      <p:sp>
+        <p:nvSpPr>
+          <p:cNvPr id="3" name="Notes Placeholder 2"/>
+          <p:cNvSpPr>
+            <a:spLocks noGrp="1"/>
+          </p:cNvSpPr>
+          <p:nvPr>
+            <p:ph type="body" idx="1"/>
+          </p:nvPr>
+        </p:nvSpPr>
+        <p:spPr/>
+        <p:txBody>
+          <a:bodyPr/>
+          <a:lstStyle/>
+          <a:p>
+            <a:r>
+              <a:rPr lang="en-US" dirty="0"/>
+              <a:t/>
+            </a:r>
+            <a:endParaRPr lang="en-US" dirty="0"/>
+          </a:p>
+        </p:txBody>
+      </p:sp>
+      <p:sp>
+        <p:nvSpPr>
+          <p:cNvPr id="4" name="Slide Number Placeholder 3"/>
+          <p:cNvSpPr>
+            <a:spLocks noGrp="1"/>
+          </p:cNvSpPr>
+          <p:nvPr>
+            <p:ph type="sldNum" sz="quarter" idx="10"/>
+          </p:nvPr>
+        </p:nvSpPr>
+        <p:spPr/>
+        <p:txBody>
+          <a:bodyPr/>
+          <a:lstStyle/>
+          <a:p>
+            <a:fld id="{F7021451-1387-4CA6-816F-3879F97B5CBC}" type="slidenum">
+              <a:rPr lang="en-US"/>
+              <a:t>10</a:t>
+            </a:fld>
+            <a:endParaRPr lang="en-US"/>
+          </a:p>
+        </p:txBody>
+      </p:sp>
+    </p:spTree>
+    <p:extLst>
+      <p:ext uri="{BB962C8B-B14F-4D97-AF65-F5344CB8AC3E}">
+        <p14:creationId xmlns:p14="http://schemas.microsoft.com/office/powerpoint/2010/main" val="1024086991"/>
+      </p:ext>
+    </p:extLst>
+  </p:cSld>
+  <p:clrMapOvr>
+    <a:masterClrMapping/>
+  </p:clrMapOvr>
+</p:notes>
+</file>
+
 <file path=ppt/notesSlides/notesSlide2.xml><?xml version="1.0" encoding="utf-8"?>
 <p:notes xmlns:a="http://schemas.openxmlformats.org/drawingml/2006/main" xmlns:r="http://schemas.openxmlformats.org/officeDocument/2006/relationships" xmlns:p="http://schemas.openxmlformats.org/presentationml/2006/main">
   <p:cSld>
@@ -1060,6 +1151,182 @@
             <a:fld id="{F7021451-1387-4CA6-816F-3879F97B5CBC}" type="slidenum">
               <a:rPr lang="en-US"/>
               <a:t>7</a:t>
+            </a:fld>
+            <a:endParaRPr lang="en-US"/>
+          </a:p>
+        </p:txBody>
+      </p:sp>
+    </p:spTree>
+    <p:extLst>
+      <p:ext uri="{BB962C8B-B14F-4D97-AF65-F5344CB8AC3E}">
+        <p14:creationId xmlns:p14="http://schemas.microsoft.com/office/powerpoint/2010/main" val="1024086991"/>
+      </p:ext>
+    </p:extLst>
+  </p:cSld>
+  <p:clrMapOvr>
+    <a:masterClrMapping/>
+  </p:clrMapOvr>
+</p:notes>
+</file>
+
+<file path=ppt/notesSlides/notesSlide8.xml><?xml version="1.0" encoding="utf-8"?>
+<p:notes xmlns:a="http://schemas.openxmlformats.org/drawingml/2006/main" xmlns:r="http://schemas.openxmlformats.org/officeDocument/2006/relationships" xmlns:p="http://schemas.openxmlformats.org/presentationml/2006/main">
+  <p:cSld>
+    <p:spTree>
+      <p:nvGrpSpPr>
+        <p:cNvPr id="1" name=""/>
+        <p:cNvGrpSpPr/>
+        <p:nvPr/>
+      </p:nvGrpSpPr>
+      <p:grpSpPr>
+        <a:xfrm>
+          <a:off x="0" y="0"/>
+          <a:ext cx="0" cy="0"/>
+          <a:chOff x="0" y="0"/>
+          <a:chExt cx="0" cy="0"/>
+        </a:xfrm>
+      </p:grpSpPr>
+      <p:sp>
+        <p:nvSpPr>
+          <p:cNvPr id="2" name="Slide Image Placeholder 1"/>
+          <p:cNvSpPr>
+            <a:spLocks noGrp="1" noRot="1" noChangeAspect="1"/>
+          </p:cNvSpPr>
+          <p:nvPr>
+            <p:ph type="sldImg"/>
+          </p:nvPr>
+        </p:nvSpPr>
+        <p:spPr/>
+      </p:sp>
+      <p:sp>
+        <p:nvSpPr>
+          <p:cNvPr id="3" name="Notes Placeholder 2"/>
+          <p:cNvSpPr>
+            <a:spLocks noGrp="1"/>
+          </p:cNvSpPr>
+          <p:nvPr>
+            <p:ph type="body" idx="1"/>
+          </p:nvPr>
+        </p:nvSpPr>
+        <p:spPr/>
+        <p:txBody>
+          <a:bodyPr/>
+          <a:lstStyle/>
+          <a:p>
+            <a:r>
+              <a:rPr lang="en-US" dirty="0"/>
+              <a:t/>
+            </a:r>
+            <a:endParaRPr lang="en-US" dirty="0"/>
+          </a:p>
+        </p:txBody>
+      </p:sp>
+      <p:sp>
+        <p:nvSpPr>
+          <p:cNvPr id="4" name="Slide Number Placeholder 3"/>
+          <p:cNvSpPr>
+            <a:spLocks noGrp="1"/>
+          </p:cNvSpPr>
+          <p:nvPr>
+            <p:ph type="sldNum" sz="quarter" idx="10"/>
+          </p:nvPr>
+        </p:nvSpPr>
+        <p:spPr/>
+        <p:txBody>
+          <a:bodyPr/>
+          <a:lstStyle/>
+          <a:p>
+            <a:fld id="{F7021451-1387-4CA6-816F-3879F97B5CBC}" type="slidenum">
+              <a:rPr lang="en-US"/>
+              <a:t>8</a:t>
+            </a:fld>
+            <a:endParaRPr lang="en-US"/>
+          </a:p>
+        </p:txBody>
+      </p:sp>
+    </p:spTree>
+    <p:extLst>
+      <p:ext uri="{BB962C8B-B14F-4D97-AF65-F5344CB8AC3E}">
+        <p14:creationId xmlns:p14="http://schemas.microsoft.com/office/powerpoint/2010/main" val="1024086991"/>
+      </p:ext>
+    </p:extLst>
+  </p:cSld>
+  <p:clrMapOvr>
+    <a:masterClrMapping/>
+  </p:clrMapOvr>
+</p:notes>
+</file>
+
+<file path=ppt/notesSlides/notesSlide9.xml><?xml version="1.0" encoding="utf-8"?>
+<p:notes xmlns:a="http://schemas.openxmlformats.org/drawingml/2006/main" xmlns:r="http://schemas.openxmlformats.org/officeDocument/2006/relationships" xmlns:p="http://schemas.openxmlformats.org/presentationml/2006/main">
+  <p:cSld>
+    <p:spTree>
+      <p:nvGrpSpPr>
+        <p:cNvPr id="1" name=""/>
+        <p:cNvGrpSpPr/>
+        <p:nvPr/>
+      </p:nvGrpSpPr>
+      <p:grpSpPr>
+        <a:xfrm>
+          <a:off x="0" y="0"/>
+          <a:ext cx="0" cy="0"/>
+          <a:chOff x="0" y="0"/>
+          <a:chExt cx="0" cy="0"/>
+        </a:xfrm>
+      </p:grpSpPr>
+      <p:sp>
+        <p:nvSpPr>
+          <p:cNvPr id="2" name="Slide Image Placeholder 1"/>
+          <p:cNvSpPr>
+            <a:spLocks noGrp="1" noRot="1" noChangeAspect="1"/>
+          </p:cNvSpPr>
+          <p:nvPr>
+            <p:ph type="sldImg"/>
+          </p:nvPr>
+        </p:nvSpPr>
+        <p:spPr/>
+      </p:sp>
+      <p:sp>
+        <p:nvSpPr>
+          <p:cNvPr id="3" name="Notes Placeholder 2"/>
+          <p:cNvSpPr>
+            <a:spLocks noGrp="1"/>
+          </p:cNvSpPr>
+          <p:nvPr>
+            <p:ph type="body" idx="1"/>
+          </p:nvPr>
+        </p:nvSpPr>
+        <p:spPr/>
+        <p:txBody>
+          <a:bodyPr/>
+          <a:lstStyle/>
+          <a:p>
+            <a:r>
+              <a:rPr lang="en-US" dirty="0"/>
+              <a:t/>
+            </a:r>
+            <a:endParaRPr lang="en-US" dirty="0"/>
+          </a:p>
+        </p:txBody>
+      </p:sp>
+      <p:sp>
+        <p:nvSpPr>
+          <p:cNvPr id="4" name="Slide Number Placeholder 3"/>
+          <p:cNvSpPr>
+            <a:spLocks noGrp="1"/>
+          </p:cNvSpPr>
+          <p:nvPr>
+            <p:ph type="sldNum" sz="quarter" idx="10"/>
+          </p:nvPr>
+        </p:nvSpPr>
+        <p:spPr/>
+        <p:txBody>
+          <a:bodyPr/>
+          <a:lstStyle/>
+          <a:p>
+            <a:fld id="{F7021451-1387-4CA6-816F-3879F97B5CBC}" type="slidenum">
+              <a:rPr lang="en-US"/>
+              <a:t>9</a:t>
             </a:fld>
             <a:endParaRPr lang="en-US"/>
           </a:p>
@@ -1475,7 +1742,7 @@
             <a:r>
               <a:rPr lang="en-US" sz="2000" dirty="0">
                 <a:solidFill>
-                  <a:srgbClr val="00796B"/>
+                  <a:srgbClr val="2563EB"/>
                 </a:solidFill>
                 <a:latin typeface="Arial" pitchFamily="34" charset="0"/>
                 <a:ea typeface="Arial" pitchFamily="34" charset="-122"/>
@@ -1526,6 +1793,38 @@
           </a:p>
         </p:txBody>
       </p:sp>
+    </p:spTree>
+  </p:cSld>
+  <p:clrMapOvr>
+    <a:masterClrMapping/>
+  </p:clrMapOvr>
+</p:sld>
+</file>
+
+<file path=ppt/slides/slide10.xml><?xml version="1.0" encoding="utf-8"?>
+<p:sld xmlns:a="http://schemas.openxmlformats.org/drawingml/2006/main" xmlns:r="http://schemas.openxmlformats.org/officeDocument/2006/relationships" xmlns:p="http://schemas.openxmlformats.org/presentationml/2006/main">
+  <p:cSld name="Slide 10">
+    <p:bg>
+      <p:bgPr>
+        <a:solidFill>
+          <a:srgbClr val="0F172A"/>
+        </a:solidFill>
+      </p:bgPr>
+    </p:bg>
+    <p:spTree>
+      <p:nvGrpSpPr>
+        <p:cNvPr id="1" name=""/>
+        <p:cNvGrpSpPr/>
+        <p:nvPr/>
+      </p:nvGrpSpPr>
+      <p:grpSpPr>
+        <a:xfrm>
+          <a:off x="0" y="0"/>
+          <a:ext cx="0" cy="0"/>
+          <a:chOff x="0" y="0"/>
+          <a:chExt cx="0" cy="0"/>
+        </a:xfrm>
+      </p:grpSpPr>
     </p:spTree>
   </p:cSld>
   <p:clrMapOvr>
@@ -1578,7 +1877,7 @@
             <a:r>
               <a:rPr lang="en-US" sz="2800" b="1" dirty="0">
                 <a:solidFill>
-                  <a:srgbClr val="00796B"/>
+                  <a:srgbClr val="2563EB"/>
                 </a:solidFill>
                 <a:latin typeface="Arial" pitchFamily="34" charset="0"/>
                 <a:ea typeface="Arial" pitchFamily="34" charset="-122"/>
@@ -1632,7 +1931,7 @@
             <a:avLst/>
           </a:prstGeom>
           <a:solidFill>
-            <a:srgbClr val="00796B"/>
+            <a:srgbClr val="2563EB"/>
           </a:solidFill>
           <a:ln/>
         </p:spPr>
@@ -1795,7 +2094,7 @@
             <a:avLst/>
           </a:prstGeom>
           <a:solidFill>
-            <a:srgbClr val="00796B"/>
+            <a:srgbClr val="2563EB"/>
           </a:solidFill>
           <a:ln/>
         </p:spPr>
@@ -1958,7 +2257,7 @@
             <a:avLst/>
           </a:prstGeom>
           <a:solidFill>
-            <a:srgbClr val="00796B"/>
+            <a:srgbClr val="2563EB"/>
           </a:solidFill>
           <a:ln/>
         </p:spPr>
@@ -2121,7 +2420,7 @@
             <a:avLst/>
           </a:prstGeom>
           <a:solidFill>
-            <a:srgbClr val="00796B"/>
+            <a:srgbClr val="2563EB"/>
           </a:solidFill>
           <a:ln/>
         </p:spPr>
@@ -2294,7 +2593,7 @@
             <a:r>
               <a:rPr lang="en-US" sz="2800" b="1" dirty="0">
                 <a:solidFill>
-                  <a:srgbClr val="00796B"/>
+                  <a:srgbClr val="2563EB"/>
                 </a:solidFill>
                 <a:latin typeface="Arial" pitchFamily="34" charset="0"/>
                 <a:ea typeface="Arial" pitchFamily="34" charset="-122"/>
@@ -2417,7 +2716,7 @@
             <a:r>
               <a:rPr lang="en-US" sz="1400" b="1" dirty="0">
                 <a:solidFill>
-                  <a:srgbClr val="00796B"/>
+                  <a:srgbClr val="2563EB"/>
                 </a:solidFill>
               </a:rPr>
               <a:t>Campos auto-completados:</a:t>
@@ -2501,7 +2800,7 @@
             <a:r>
               <a:rPr lang="en-US" sz="2800" b="1" dirty="0">
                 <a:solidFill>
-                  <a:srgbClr val="00796B"/>
+                  <a:srgbClr val="2563EB"/>
                 </a:solidFill>
                 <a:latin typeface="Arial" pitchFamily="34" charset="0"/>
                 <a:ea typeface="Arial" pitchFamily="34" charset="-122"/>
@@ -2603,7 +2902,7 @@
             <a:r>
               <a:rPr lang="en-US" sz="1800" b="1" dirty="0">
                 <a:solidFill>
-                  <a:srgbClr val="00796B"/>
+                  <a:srgbClr val="2563EB"/>
                 </a:solidFill>
                 <a:latin typeface="Arial" pitchFamily="34" charset="0"/>
                 <a:ea typeface="Arial" pitchFamily="34" charset="-122"/>
@@ -2715,7 +3014,7 @@
             <a:r>
               <a:rPr lang="en-US" sz="1000" i="1" dirty="0">
                 <a:solidFill>
-                  <a:srgbClr val="00796B"/>
+                  <a:srgbClr val="2563EB"/>
                 </a:solidFill>
                 <a:latin typeface="Arial" pitchFamily="34" charset="0"/>
                 <a:ea typeface="Arial" pitchFamily="34" charset="-122"/>
@@ -2817,7 +3116,7 @@
             <a:r>
               <a:rPr lang="en-US" sz="1800" b="1" dirty="0">
                 <a:solidFill>
-                  <a:srgbClr val="00796B"/>
+                  <a:srgbClr val="2563EB"/>
                 </a:solidFill>
                 <a:latin typeface="Arial" pitchFamily="34" charset="0"/>
                 <a:ea typeface="Arial" pitchFamily="34" charset="-122"/>
@@ -2929,7 +3228,7 @@
             <a:r>
               <a:rPr lang="en-US" sz="1000" i="1" dirty="0">
                 <a:solidFill>
-                  <a:srgbClr val="00796B"/>
+                  <a:srgbClr val="2563EB"/>
                 </a:solidFill>
                 <a:latin typeface="Arial" pitchFamily="34" charset="0"/>
                 <a:ea typeface="Arial" pitchFamily="34" charset="-122"/>
@@ -3031,7 +3330,7 @@
             <a:r>
               <a:rPr lang="en-US" sz="1800" b="1" dirty="0">
                 <a:solidFill>
-                  <a:srgbClr val="00796B"/>
+                  <a:srgbClr val="2563EB"/>
                 </a:solidFill>
                 <a:latin typeface="Arial" pitchFamily="34" charset="0"/>
                 <a:ea typeface="Arial" pitchFamily="34" charset="-122"/>
@@ -3143,7 +3442,7 @@
             <a:r>
               <a:rPr lang="en-US" sz="1000" i="1" dirty="0">
                 <a:solidFill>
-                  <a:srgbClr val="00796B"/>
+                  <a:srgbClr val="2563EB"/>
                 </a:solidFill>
                 <a:latin typeface="Arial" pitchFamily="34" charset="0"/>
                 <a:ea typeface="Arial" pitchFamily="34" charset="-122"/>
@@ -3207,7 +3506,7 @@
             <a:r>
               <a:rPr lang="en-US" sz="2800" b="1" dirty="0">
                 <a:solidFill>
-                  <a:srgbClr val="00796B"/>
+                  <a:srgbClr val="2563EB"/>
                 </a:solidFill>
                 <a:latin typeface="Arial" pitchFamily="34" charset="0"/>
                 <a:ea typeface="Arial" pitchFamily="34" charset="-122"/>
@@ -3270,7 +3569,7 @@
             <a:r>
               <a:rPr lang="en-US" sz="1300" b="1" dirty="0">
                 <a:solidFill>
-                  <a:srgbClr val="00796B"/>
+                  <a:srgbClr val="2563EB"/>
                 </a:solidFill>
               </a:rPr>
               <a:t>📦 NAVEGACIÓN
@@ -3318,7 +3617,7 @@
             <a:r>
               <a:rPr lang="en-US" sz="1300" b="1" dirty="0">
                 <a:solidFill>
-                  <a:srgbClr val="00796B"/>
+                  <a:srgbClr val="2563EB"/>
                 </a:solidFill>
               </a:rPr>
               <a:t>⚡ ACCIONES
@@ -3366,7 +3665,7 @@
             <a:r>
               <a:rPr lang="en-US" sz="1300" b="1" dirty="0">
                 <a:solidFill>
-                  <a:srgbClr val="00796B"/>
+                  <a:srgbClr val="2563EB"/>
                 </a:solidFill>
               </a:rPr>
               <a:t>📥 EXPORTAR (context-aware)
@@ -3452,7 +3751,7 @@
             <a:r>
               <a:rPr lang="en-US" sz="2800" b="1" dirty="0">
                 <a:solidFill>
-                  <a:srgbClr val="00796B"/>
+                  <a:srgbClr val="2563EB"/>
                 </a:solidFill>
                 <a:latin typeface="Arial" pitchFamily="34" charset="0"/>
                 <a:ea typeface="Arial" pitchFamily="34" charset="-122"/>
@@ -3479,7 +3778,7 @@
             <a:avLst/>
           </a:prstGeom>
           <a:solidFill>
-            <a:srgbClr val="E0F2F1"/>
+            <a:srgbClr val="DBEAFE"/>
           </a:solidFill>
           <a:ln/>
         </p:spPr>
@@ -3511,7 +3810,7 @@
             <a:r>
               <a:rPr lang="en-US" sz="1300" b="1" dirty="0">
                 <a:solidFill>
-                  <a:srgbClr val="00796B"/>
+                  <a:srgbClr val="2563EB"/>
                 </a:solidFill>
                 <a:latin typeface="Consolas" pitchFamily="34" charset="0"/>
                 <a:ea typeface="Consolas" pitchFamily="34" charset="-122"/>
@@ -3609,7 +3908,7 @@
             <a:r>
               <a:rPr lang="en-US" sz="1300" b="1" dirty="0">
                 <a:solidFill>
-                  <a:srgbClr val="00796B"/>
+                  <a:srgbClr val="2563EB"/>
                 </a:solidFill>
                 <a:latin typeface="Consolas" pitchFamily="34" charset="0"/>
                 <a:ea typeface="Consolas" pitchFamily="34" charset="-122"/>
@@ -3675,7 +3974,7 @@
             <a:avLst/>
           </a:prstGeom>
           <a:solidFill>
-            <a:srgbClr val="E0F2F1"/>
+            <a:srgbClr val="DBEAFE"/>
           </a:solidFill>
           <a:ln/>
         </p:spPr>
@@ -3707,7 +4006,7 @@
             <a:r>
               <a:rPr lang="en-US" sz="1300" b="1" dirty="0">
                 <a:solidFill>
-                  <a:srgbClr val="00796B"/>
+                  <a:srgbClr val="2563EB"/>
                 </a:solidFill>
                 <a:latin typeface="Consolas" pitchFamily="34" charset="0"/>
                 <a:ea typeface="Consolas" pitchFamily="34" charset="-122"/>
@@ -3805,7 +4104,7 @@
             <a:r>
               <a:rPr lang="en-US" sz="1300" b="1" dirty="0">
                 <a:solidFill>
-                  <a:srgbClr val="00796B"/>
+                  <a:srgbClr val="2563EB"/>
                 </a:solidFill>
                 <a:latin typeface="Consolas" pitchFamily="34" charset="0"/>
                 <a:ea typeface="Consolas" pitchFamily="34" charset="-122"/>
@@ -3871,7 +4170,7 @@
             <a:avLst/>
           </a:prstGeom>
           <a:solidFill>
-            <a:srgbClr val="E0F2F1"/>
+            <a:srgbClr val="DBEAFE"/>
           </a:solidFill>
           <a:ln/>
         </p:spPr>
@@ -3903,7 +4202,7 @@
             <a:r>
               <a:rPr lang="en-US" sz="1300" b="1" dirty="0">
                 <a:solidFill>
-                  <a:srgbClr val="00796B"/>
+                  <a:srgbClr val="2563EB"/>
                 </a:solidFill>
                 <a:latin typeface="Consolas" pitchFamily="34" charset="0"/>
                 <a:ea typeface="Consolas" pitchFamily="34" charset="-122"/>
@@ -4001,7 +4300,7 @@
             <a:r>
               <a:rPr lang="en-US" sz="1300" b="1" dirty="0">
                 <a:solidFill>
-                  <a:srgbClr val="00796B"/>
+                  <a:srgbClr val="2563EB"/>
                 </a:solidFill>
                 <a:latin typeface="Consolas" pitchFamily="34" charset="0"/>
                 <a:ea typeface="Consolas" pitchFamily="34" charset="-122"/>
@@ -4067,7 +4366,7 @@
             <a:avLst/>
           </a:prstGeom>
           <a:solidFill>
-            <a:srgbClr val="E0F2F1"/>
+            <a:srgbClr val="DBEAFE"/>
           </a:solidFill>
           <a:ln/>
         </p:spPr>
@@ -4099,7 +4398,7 @@
             <a:r>
               <a:rPr lang="en-US" sz="1300" b="1" dirty="0">
                 <a:solidFill>
-                  <a:srgbClr val="00796B"/>
+                  <a:srgbClr val="2563EB"/>
                 </a:solidFill>
                 <a:latin typeface="Consolas" pitchFamily="34" charset="0"/>
                 <a:ea typeface="Consolas" pitchFamily="34" charset="-122"/>
@@ -4161,6 +4460,1269 @@
 <file path=ppt/slides/slide7.xml><?xml version="1.0" encoding="utf-8"?>
 <p:sld xmlns:a="http://schemas.openxmlformats.org/drawingml/2006/main" xmlns:r="http://schemas.openxmlformats.org/officeDocument/2006/relationships" xmlns:p="http://schemas.openxmlformats.org/presentationml/2006/main">
   <p:cSld name="Slide 7">
+    <p:spTree>
+      <p:nvGrpSpPr>
+        <p:cNvPr id="1" name=""/>
+        <p:cNvGrpSpPr/>
+        <p:nvPr/>
+      </p:nvGrpSpPr>
+      <p:grpSpPr>
+        <a:xfrm>
+          <a:off x="0" y="0"/>
+          <a:ext cx="0" cy="0"/>
+          <a:chOff x="0" y="0"/>
+          <a:chExt cx="0" cy="0"/>
+        </a:xfrm>
+      </p:grpSpPr>
+      <p:sp>
+        <p:nvSpPr>
+          <p:cNvPr id="2" name="Text 0"/>
+          <p:cNvSpPr/>
+          <p:nvPr/>
+        </p:nvSpPr>
+        <p:spPr>
+          <a:xfrm>
+            <a:off x="457200" y="274320"/>
+            <a:ext cx="8229600" cy="731520"/>
+          </a:xfrm>
+          <a:prstGeom prst="rect">
+            <a:avLst/>
+          </a:prstGeom>
+          <a:noFill/>
+          <a:ln/>
+        </p:spPr>
+        <p:txBody>
+          <a:bodyPr wrap="square" rtlCol="0" anchor="ctr"/>
+          <a:lstStyle/>
+          <a:p>
+            <a:pPr indent="0" marL="0">
+              <a:buNone/>
+            </a:pPr>
+            <a:r>
+              <a:rPr lang="en-US" sz="2800" b="1" dirty="0">
+                <a:solidFill>
+                  <a:srgbClr val="2563EB"/>
+                </a:solidFill>
+                <a:latin typeface="Arial" pitchFamily="34" charset="0"/>
+                <a:ea typeface="Arial" pitchFamily="34" charset="-122"/>
+                <a:cs typeface="Arial" pitchFamily="34" charset="-120"/>
+              </a:rPr>
+              <a:t>Tabla de Partidas Mejorada</a:t>
+            </a:r>
+            <a:endParaRPr lang="en-US" sz="2800" dirty="0"/>
+          </a:p>
+        </p:txBody>
+      </p:sp>
+      <p:sp>
+        <p:nvSpPr>
+          <p:cNvPr id="3" name="Text 1"/>
+          <p:cNvSpPr/>
+          <p:nvPr/>
+        </p:nvSpPr>
+        <p:spPr>
+          <a:xfrm>
+            <a:off x="457200" y="1188720"/>
+            <a:ext cx="8229600" cy="3840480"/>
+          </a:xfrm>
+          <a:prstGeom prst="rect">
+            <a:avLst/>
+          </a:prstGeom>
+          <a:noFill/>
+          <a:ln/>
+        </p:spPr>
+        <p:txBody>
+          <a:bodyPr wrap="square" rtlCol="0" anchor="ctr"/>
+          <a:lstStyle/>
+          <a:p>
+            <a:pPr indent="0" marL="0">
+              <a:buNone/>
+            </a:pPr>
+            <a:r>
+              <a:rPr lang="en-US" sz="1400" b="1" dirty="0">
+                <a:solidFill>
+                  <a:srgbClr val="1E293B"/>
+                </a:solidFill>
+              </a:rPr>
+              <a:t>13 columnas con colgroup simétrico
+</a:t>
+            </a:r>
+            <a:pPr indent="0" marL="0">
+              <a:buNone/>
+            </a:pPr>
+            <a:r>
+              <a:rPr lang="en-US" sz="600" dirty="0">
+                <a:solidFill>
+                  <a:srgbClr val="000000"/>
+                </a:solidFill>
+              </a:rPr>
+              <a:t>
+</a:t>
+            </a:r>
+            <a:pPr indent="0" marL="0">
+              <a:buNone/>
+            </a:pPr>
+            <a:r>
+              <a:rPr lang="en-US" sz="1200" dirty="0">
+                <a:solidFill>
+                  <a:srgbClr val="64748B"/>
+                </a:solidFill>
+              </a:rPr>
+              <a:t>• Encabezados a 2 líneas (etiqueta + unidad)
+</a:t>
+            </a:r>
+            <a:pPr indent="0" marL="0">
+              <a:buNone/>
+            </a:pPr>
+            <a:r>
+              <a:rPr lang="en-US" sz="1200" dirty="0">
+                <a:solidFill>
+                  <a:srgbClr val="64748B"/>
+                </a:solidFill>
+              </a:rPr>
+              <a:t>• Ordenamiento en headers (click → ▲▼)
+</a:t>
+            </a:r>
+            <a:pPr indent="0" marL="0">
+              <a:buNone/>
+            </a:pPr>
+            <a:r>
+              <a:rPr lang="en-US" sz="1200" dirty="0">
+                <a:solidFill>
+                  <a:srgbClr val="64748B"/>
+                </a:solidFill>
+              </a:rPr>
+              <a:t>• Filtro de stock: Todos / Con stock / Sin stock
+</a:t>
+            </a:r>
+            <a:pPr indent="0" marL="0">
+              <a:buNone/>
+            </a:pPr>
+            <a:r>
+              <a:rPr lang="en-US" sz="1200" dirty="0">
+                <a:solidFill>
+                  <a:srgbClr val="64748B"/>
+                </a:solidFill>
+              </a:rPr>
+              <a:t>• Nueva columna CAJAS para logística
+</a:t>
+            </a:r>
+            <a:pPr indent="0" marL="0">
+              <a:buNone/>
+            </a:pPr>
+            <a:r>
+              <a:rPr lang="en-US" sz="600" dirty="0">
+                <a:solidFill>
+                  <a:srgbClr val="000000"/>
+                </a:solidFill>
+              </a:rPr>
+              <a:t>
+</a:t>
+            </a:r>
+            <a:pPr indent="0" marL="0">
+              <a:buNone/>
+            </a:pPr>
+            <a:r>
+              <a:rPr lang="en-US" sz="1300" b="1" dirty="0">
+                <a:solidFill>
+                  <a:srgbClr val="2563EB"/>
+                </a:solidFill>
+              </a:rPr>
+              <a:t>Distribución de ancho (%):</a:t>
+            </a:r>
+            <a:pPr indent="0" marL="0">
+              <a:buNone/>
+            </a:pPr>
+            <a:r>
+              <a:rPr lang="en-US" sz="600" dirty="0">
+                <a:solidFill>
+                  <a:srgbClr val="000000"/>
+                </a:solidFill>
+              </a:rPr>
+              <a:t>
+</a:t>
+            </a:r>
+            <a:pPr indent="0" marL="0">
+              <a:buNone/>
+            </a:pPr>
+            <a:r>
+              <a:rPr lang="en-US" sz="1000" dirty="0">
+                <a:solidFill>
+                  <a:srgbClr val="1E293B"/>
+                </a:solidFill>
+              </a:rPr>
+              <a:t>N° 3% | Cant 6% | U/M 4% | SKU 7% | Desc 24% | P.Lista 7% | Dto1 5% | Dto2 5% | Neto 9% | P.Unit 7% | TOTAL 10% | Cajas 6% | Tipo 7%</a:t>
+            </a:r>
+            <a:pPr indent="0" marL="0">
+              <a:buNone/>
+            </a:pPr>
+            <a:r>
+              <a:rPr lang="en-US" sz="600" dirty="0">
+                <a:solidFill>
+                  <a:srgbClr val="000000"/>
+                </a:solidFill>
+              </a:rPr>
+              <a:t>
+</a:t>
+            </a:r>
+            <a:pPr indent="0" marL="0">
+              <a:buNone/>
+            </a:pPr>
+            <a:r>
+              <a:rPr lang="en-US" sz="1100" dirty="0">
+                <a:solidFill>
+                  <a:srgbClr val="64748B"/>
+                </a:solidFill>
+              </a:rPr>
+              <a:t>Descripción con clamp de 2 líneas (máx 40 caracteres)</a:t>
+            </a:r>
+            <a:endParaRPr lang="en-US" sz="1400" dirty="0"/>
+          </a:p>
+        </p:txBody>
+      </p:sp>
+      <p:sp>
+        <p:nvSpPr>
+          <p:cNvPr id="4" name="Text 2"/>
+          <p:cNvSpPr/>
+          <p:nvPr/>
+        </p:nvSpPr>
+        <p:spPr>
+          <a:xfrm>
+            <a:off x="457200" y="1371600"/>
+            <a:ext cx="8229600" cy="914400"/>
+          </a:xfrm>
+          <a:prstGeom prst="rect">
+            <a:avLst/>
+          </a:prstGeom>
+          <a:noFill/>
+          <a:ln/>
+        </p:spPr>
+        <p:txBody>
+          <a:bodyPr wrap="square" rtlCol="0" anchor="ctr"/>
+          <a:lstStyle/>
+          <a:p>
+            <a:pPr algn="ctr" indent="0" marL="0">
+              <a:buNone/>
+            </a:pPr>
+            <a:r>
+              <a:rPr lang="en-US" sz="3200" b="1" dirty="0">
+                <a:solidFill>
+                  <a:srgbClr val="FFFFFF"/>
+                </a:solidFill>
+                <a:latin typeface="Arial" pitchFamily="34" charset="0"/>
+                <a:ea typeface="Arial" pitchFamily="34" charset="-122"/>
+                <a:cs typeface="Arial" pitchFamily="34" charset="-120"/>
+              </a:rPr>
+              <a:t>¿Necesitas ayuda?</a:t>
+            </a:r>
+            <a:endParaRPr lang="en-US" sz="3200" dirty="0"/>
+          </a:p>
+        </p:txBody>
+      </p:sp>
+      <p:sp>
+        <p:nvSpPr>
+          <p:cNvPr id="5" name="Text 3"/>
+          <p:cNvSpPr/>
+          <p:nvPr/>
+        </p:nvSpPr>
+        <p:spPr>
+          <a:xfrm>
+            <a:off x="457200" y="2743200"/>
+            <a:ext cx="8229600" cy="548640"/>
+          </a:xfrm>
+          <a:prstGeom prst="rect">
+            <a:avLst/>
+          </a:prstGeom>
+          <a:noFill/>
+          <a:ln/>
+        </p:spPr>
+        <p:txBody>
+          <a:bodyPr wrap="square" rtlCol="0" anchor="ctr"/>
+          <a:lstStyle/>
+          <a:p>
+            <a:pPr algn="ctr" indent="0" marL="0">
+              <a:buNone/>
+            </a:pPr>
+            <a:r>
+              <a:rPr lang="en-US" sz="1800" dirty="0">
+                <a:solidFill>
+                  <a:srgbClr val="2563EB"/>
+                </a:solidFill>
+                <a:latin typeface="Arial" pitchFamily="34" charset="0"/>
+                <a:ea typeface="Arial" pitchFamily="34" charset="-122"/>
+                <a:cs typeface="Arial" pitchFamily="34" charset="-120"/>
+              </a:rPr>
+              <a:t>G360 by ccusi</a:t>
+            </a:r>
+            <a:endParaRPr lang="en-US" sz="1800" dirty="0"/>
+          </a:p>
+        </p:txBody>
+      </p:sp>
+      <p:sp>
+        <p:nvSpPr>
+          <p:cNvPr id="6" name="Text 4"/>
+          <p:cNvSpPr/>
+          <p:nvPr/>
+        </p:nvSpPr>
+        <p:spPr>
+          <a:xfrm>
+            <a:off x="457200" y="3657600"/>
+            <a:ext cx="8229600" cy="457200"/>
+          </a:xfrm>
+          <a:prstGeom prst="rect">
+            <a:avLst/>
+          </a:prstGeom>
+          <a:noFill/>
+          <a:ln/>
+        </p:spPr>
+        <p:txBody>
+          <a:bodyPr wrap="square" rtlCol="0" anchor="ctr"/>
+          <a:lstStyle/>
+          <a:p>
+            <a:pPr algn="ctr" indent="0" marL="0">
+              <a:buNone/>
+            </a:pPr>
+            <a:r>
+              <a:rPr lang="en-US" sz="1400" dirty="0">
+                <a:solidFill>
+                  <a:srgbClr val="64748B"/>
+                </a:solidFill>
+                <a:latin typeface="Arial" pitchFamily="34" charset="0"/>
+                <a:ea typeface="Arial" pitchFamily="34" charset="-122"/>
+                <a:cs typeface="Arial" pitchFamily="34" charset="-120"/>
+              </a:rPr>
+              <a:t>CIPSA OrderX v6.0.0</a:t>
+            </a:r>
+            <a:endParaRPr lang="en-US" sz="1400" dirty="0"/>
+          </a:p>
+        </p:txBody>
+      </p:sp>
+    </p:spTree>
+  </p:cSld>
+  <p:clrMapOvr>
+    <a:masterClrMapping/>
+  </p:clrMapOvr>
+</p:sld>
+</file>
+
+<file path=ppt/slides/slide8.xml><?xml version="1.0" encoding="utf-8"?>
+<p:sld xmlns:a="http://schemas.openxmlformats.org/drawingml/2006/main" xmlns:r="http://schemas.openxmlformats.org/officeDocument/2006/relationships" xmlns:p="http://schemas.openxmlformats.org/presentationml/2006/main">
+  <p:cSld name="Slide 8">
+    <p:spTree>
+      <p:nvGrpSpPr>
+        <p:cNvPr id="1" name=""/>
+        <p:cNvGrpSpPr/>
+        <p:nvPr/>
+      </p:nvGrpSpPr>
+      <p:grpSpPr>
+        <a:xfrm>
+          <a:off x="0" y="0"/>
+          <a:ext cx="0" cy="0"/>
+          <a:chOff x="0" y="0"/>
+          <a:chExt cx="0" cy="0"/>
+        </a:xfrm>
+      </p:grpSpPr>
+      <p:sp>
+        <p:nvSpPr>
+          <p:cNvPr id="2" name="Text 0"/>
+          <p:cNvSpPr/>
+          <p:nvPr/>
+        </p:nvSpPr>
+        <p:spPr>
+          <a:xfrm>
+            <a:off x="457200" y="274320"/>
+            <a:ext cx="8229600" cy="731520"/>
+          </a:xfrm>
+          <a:prstGeom prst="rect">
+            <a:avLst/>
+          </a:prstGeom>
+          <a:noFill/>
+          <a:ln/>
+        </p:spPr>
+        <p:txBody>
+          <a:bodyPr wrap="square" rtlCol="0" anchor="ctr"/>
+          <a:lstStyle/>
+          <a:p>
+            <a:pPr indent="0" marL="0">
+              <a:buNone/>
+            </a:pPr>
+            <a:r>
+              <a:rPr lang="en-US" sz="2800" b="1" dirty="0">
+                <a:solidFill>
+                  <a:srgbClr val="2563EB"/>
+                </a:solidFill>
+                <a:latin typeface="Arial" pitchFamily="34" charset="0"/>
+                <a:ea typeface="Arial" pitchFamily="34" charset="-122"/>
+                <a:cs typeface="Arial" pitchFamily="34" charset="-120"/>
+              </a:rPr>
+              <a:t>Paleta Corporativa Azul</a:t>
+            </a:r>
+            <a:endParaRPr lang="en-US" sz="2800" dirty="0"/>
+          </a:p>
+        </p:txBody>
+      </p:sp>
+      <p:sp>
+        <p:nvSpPr>
+          <p:cNvPr id="3" name="Shape 1"/>
+          <p:cNvSpPr/>
+          <p:nvPr/>
+        </p:nvSpPr>
+        <p:spPr>
+          <a:xfrm>
+            <a:off x="457200" y="1188720"/>
+            <a:ext cx="8229600" cy="502920"/>
+          </a:xfrm>
+          <a:prstGeom prst="roundRect">
+            <a:avLst/>
+          </a:prstGeom>
+          <a:solidFill>
+            <a:srgbClr val="2563EB"/>
+          </a:solidFill>
+          <a:ln w="6350">
+            <a:solidFill>
+              <a:srgbClr val="E2E8F0"/>
+            </a:solidFill>
+            <a:prstDash val="solid"/>
+          </a:ln>
+        </p:spPr>
+      </p:sp>
+      <p:sp>
+        <p:nvSpPr>
+          <p:cNvPr id="4" name="Text 2"/>
+          <p:cNvSpPr/>
+          <p:nvPr/>
+        </p:nvSpPr>
+        <p:spPr>
+          <a:xfrm>
+            <a:off x="640080" y="1188720"/>
+            <a:ext cx="2286000" cy="502920"/>
+          </a:xfrm>
+          <a:prstGeom prst="rect">
+            <a:avLst/>
+          </a:prstGeom>
+          <a:noFill/>
+          <a:ln/>
+        </p:spPr>
+        <p:txBody>
+          <a:bodyPr wrap="square" rtlCol="0" anchor="ctr"/>
+          <a:lstStyle/>
+          <a:p>
+            <a:pPr indent="0" marL="0">
+              <a:buNone/>
+            </a:pPr>
+            <a:r>
+              <a:rPr lang="en-US" sz="1200" b="1" dirty="0">
+                <a:solidFill>
+                  <a:srgbClr val="FFFFFF"/>
+                </a:solidFill>
+                <a:latin typeface="Arial" pitchFamily="34" charset="0"/>
+                <a:ea typeface="Arial" pitchFamily="34" charset="-122"/>
+                <a:cs typeface="Arial" pitchFamily="34" charset="-120"/>
+              </a:rPr>
+              <a:t>Acento Principal</a:t>
+            </a:r>
+            <a:endParaRPr lang="en-US" sz="1200" dirty="0"/>
+          </a:p>
+        </p:txBody>
+      </p:sp>
+      <p:sp>
+        <p:nvSpPr>
+          <p:cNvPr id="5" name="Text 3"/>
+          <p:cNvSpPr/>
+          <p:nvPr/>
+        </p:nvSpPr>
+        <p:spPr>
+          <a:xfrm>
+            <a:off x="3017520" y="1188720"/>
+            <a:ext cx="1371600" cy="502920"/>
+          </a:xfrm>
+          <a:prstGeom prst="rect">
+            <a:avLst/>
+          </a:prstGeom>
+          <a:noFill/>
+          <a:ln/>
+        </p:spPr>
+        <p:txBody>
+          <a:bodyPr wrap="square" rtlCol="0" anchor="ctr"/>
+          <a:lstStyle/>
+          <a:p>
+            <a:pPr indent="0" marL="0">
+              <a:buNone/>
+            </a:pPr>
+            <a:r>
+              <a:rPr lang="en-US" sz="1100" dirty="0">
+                <a:solidFill>
+                  <a:srgbClr val="FFFFFF"/>
+                </a:solidFill>
+                <a:latin typeface="Consolas" pitchFamily="34" charset="0"/>
+                <a:ea typeface="Consolas" pitchFamily="34" charset="-122"/>
+                <a:cs typeface="Consolas" pitchFamily="34" charset="-120"/>
+              </a:rPr>
+              <a:t>#2563EB</a:t>
+            </a:r>
+            <a:endParaRPr lang="en-US" sz="1100" dirty="0"/>
+          </a:p>
+        </p:txBody>
+      </p:sp>
+      <p:sp>
+        <p:nvSpPr>
+          <p:cNvPr id="6" name="Text 4"/>
+          <p:cNvSpPr/>
+          <p:nvPr/>
+        </p:nvSpPr>
+        <p:spPr>
+          <a:xfrm>
+            <a:off x="4572000" y="1188720"/>
+            <a:ext cx="3657600" cy="502920"/>
+          </a:xfrm>
+          <a:prstGeom prst="rect">
+            <a:avLst/>
+          </a:prstGeom>
+          <a:noFill/>
+          <a:ln/>
+        </p:spPr>
+        <p:txBody>
+          <a:bodyPr wrap="square" rtlCol="0" anchor="ctr"/>
+          <a:lstStyle/>
+          <a:p>
+            <a:pPr indent="0" marL="0">
+              <a:buNone/>
+            </a:pPr>
+            <a:r>
+              <a:rPr lang="en-US" sz="1100" dirty="0">
+                <a:solidFill>
+                  <a:srgbClr val="FFFFFF"/>
+                </a:solidFill>
+                <a:latin typeface="Arial" pitchFamily="34" charset="0"/>
+                <a:ea typeface="Arial" pitchFamily="34" charset="-122"/>
+                <a:cs typeface="Arial" pitchFamily="34" charset="-120"/>
+              </a:rPr>
+              <a:t>Azul corporativo</a:t>
+            </a:r>
+            <a:endParaRPr lang="en-US" sz="1100" dirty="0"/>
+          </a:p>
+        </p:txBody>
+      </p:sp>
+      <p:sp>
+        <p:nvSpPr>
+          <p:cNvPr id="7" name="Shape 5"/>
+          <p:cNvSpPr/>
+          <p:nvPr/>
+        </p:nvSpPr>
+        <p:spPr>
+          <a:xfrm>
+            <a:off x="457200" y="1783080"/>
+            <a:ext cx="8229600" cy="502920"/>
+          </a:xfrm>
+          <a:prstGeom prst="roundRect">
+            <a:avLst/>
+          </a:prstGeom>
+          <a:solidFill>
+            <a:srgbClr val="1D4ED8"/>
+          </a:solidFill>
+          <a:ln w="6350">
+            <a:solidFill>
+              <a:srgbClr val="E2E8F0"/>
+            </a:solidFill>
+            <a:prstDash val="solid"/>
+          </a:ln>
+        </p:spPr>
+      </p:sp>
+      <p:sp>
+        <p:nvSpPr>
+          <p:cNvPr id="8" name="Text 6"/>
+          <p:cNvSpPr/>
+          <p:nvPr/>
+        </p:nvSpPr>
+        <p:spPr>
+          <a:xfrm>
+            <a:off x="640080" y="1783080"/>
+            <a:ext cx="2286000" cy="502920"/>
+          </a:xfrm>
+          <a:prstGeom prst="rect">
+            <a:avLst/>
+          </a:prstGeom>
+          <a:noFill/>
+          <a:ln/>
+        </p:spPr>
+        <p:txBody>
+          <a:bodyPr wrap="square" rtlCol="0" anchor="ctr"/>
+          <a:lstStyle/>
+          <a:p>
+            <a:pPr indent="0" marL="0">
+              <a:buNone/>
+            </a:pPr>
+            <a:r>
+              <a:rPr lang="en-US" sz="1200" b="1" dirty="0">
+                <a:solidFill>
+                  <a:srgbClr val="FFFFFF"/>
+                </a:solidFill>
+                <a:latin typeface="Arial" pitchFamily="34" charset="0"/>
+                <a:ea typeface="Arial" pitchFamily="34" charset="-122"/>
+                <a:cs typeface="Arial" pitchFamily="34" charset="-120"/>
+              </a:rPr>
+              <a:t>Acento Claro</a:t>
+            </a:r>
+            <a:endParaRPr lang="en-US" sz="1200" dirty="0"/>
+          </a:p>
+        </p:txBody>
+      </p:sp>
+      <p:sp>
+        <p:nvSpPr>
+          <p:cNvPr id="9" name="Text 7"/>
+          <p:cNvSpPr/>
+          <p:nvPr/>
+        </p:nvSpPr>
+        <p:spPr>
+          <a:xfrm>
+            <a:off x="3017520" y="1783080"/>
+            <a:ext cx="1371600" cy="502920"/>
+          </a:xfrm>
+          <a:prstGeom prst="rect">
+            <a:avLst/>
+          </a:prstGeom>
+          <a:noFill/>
+          <a:ln/>
+        </p:spPr>
+        <p:txBody>
+          <a:bodyPr wrap="square" rtlCol="0" anchor="ctr"/>
+          <a:lstStyle/>
+          <a:p>
+            <a:pPr indent="0" marL="0">
+              <a:buNone/>
+            </a:pPr>
+            <a:r>
+              <a:rPr lang="en-US" sz="1100" dirty="0">
+                <a:solidFill>
+                  <a:srgbClr val="FFFFFF"/>
+                </a:solidFill>
+                <a:latin typeface="Consolas" pitchFamily="34" charset="0"/>
+                <a:ea typeface="Consolas" pitchFamily="34" charset="-122"/>
+                <a:cs typeface="Consolas" pitchFamily="34" charset="-120"/>
+              </a:rPr>
+              <a:t>#1D4ED8</a:t>
+            </a:r>
+            <a:endParaRPr lang="en-US" sz="1100" dirty="0"/>
+          </a:p>
+        </p:txBody>
+      </p:sp>
+      <p:sp>
+        <p:nvSpPr>
+          <p:cNvPr id="10" name="Text 8"/>
+          <p:cNvSpPr/>
+          <p:nvPr/>
+        </p:nvSpPr>
+        <p:spPr>
+          <a:xfrm>
+            <a:off x="4572000" y="1783080"/>
+            <a:ext cx="3657600" cy="502920"/>
+          </a:xfrm>
+          <a:prstGeom prst="rect">
+            <a:avLst/>
+          </a:prstGeom>
+          <a:noFill/>
+          <a:ln/>
+        </p:spPr>
+        <p:txBody>
+          <a:bodyPr wrap="square" rtlCol="0" anchor="ctr"/>
+          <a:lstStyle/>
+          <a:p>
+            <a:pPr indent="0" marL="0">
+              <a:buNone/>
+            </a:pPr>
+            <a:r>
+              <a:rPr lang="en-US" sz="1100" dirty="0">
+                <a:solidFill>
+                  <a:srgbClr val="FFFFFF"/>
+                </a:solidFill>
+                <a:latin typeface="Arial" pitchFamily="34" charset="0"/>
+                <a:ea typeface="Arial" pitchFamily="34" charset="-122"/>
+                <a:cs typeface="Arial" pitchFamily="34" charset="-120"/>
+              </a:rPr>
+              <a:t>Modo claro</a:t>
+            </a:r>
+            <a:endParaRPr lang="en-US" sz="1100" dirty="0"/>
+          </a:p>
+        </p:txBody>
+      </p:sp>
+      <p:sp>
+        <p:nvSpPr>
+          <p:cNvPr id="11" name="Shape 9"/>
+          <p:cNvSpPr/>
+          <p:nvPr/>
+        </p:nvSpPr>
+        <p:spPr>
+          <a:xfrm>
+            <a:off x="457200" y="2377440"/>
+            <a:ext cx="8229600" cy="502920"/>
+          </a:xfrm>
+          <a:prstGeom prst="roundRect">
+            <a:avLst/>
+          </a:prstGeom>
+          <a:solidFill>
+            <a:srgbClr val="1E40AF"/>
+          </a:solidFill>
+          <a:ln w="6350">
+            <a:solidFill>
+              <a:srgbClr val="E2E8F0"/>
+            </a:solidFill>
+            <a:prstDash val="solid"/>
+          </a:ln>
+        </p:spPr>
+      </p:sp>
+      <p:sp>
+        <p:nvSpPr>
+          <p:cNvPr id="12" name="Text 10"/>
+          <p:cNvSpPr/>
+          <p:nvPr/>
+        </p:nvSpPr>
+        <p:spPr>
+          <a:xfrm>
+            <a:off x="640080" y="2377440"/>
+            <a:ext cx="2286000" cy="502920"/>
+          </a:xfrm>
+          <a:prstGeom prst="rect">
+            <a:avLst/>
+          </a:prstGeom>
+          <a:noFill/>
+          <a:ln/>
+        </p:spPr>
+        <p:txBody>
+          <a:bodyPr wrap="square" rtlCol="0" anchor="ctr"/>
+          <a:lstStyle/>
+          <a:p>
+            <a:pPr indent="0" marL="0">
+              <a:buNone/>
+            </a:pPr>
+            <a:r>
+              <a:rPr lang="en-US" sz="1200" b="1" dirty="0">
+                <a:solidFill>
+                  <a:srgbClr val="FFFFFF"/>
+                </a:solidFill>
+                <a:latin typeface="Arial" pitchFamily="34" charset="0"/>
+                <a:ea typeface="Arial" pitchFamily="34" charset="-122"/>
+                <a:cs typeface="Arial" pitchFamily="34" charset="-120"/>
+              </a:rPr>
+              <a:t>Header</a:t>
+            </a:r>
+            <a:endParaRPr lang="en-US" sz="1200" dirty="0"/>
+          </a:p>
+        </p:txBody>
+      </p:sp>
+      <p:sp>
+        <p:nvSpPr>
+          <p:cNvPr id="13" name="Text 11"/>
+          <p:cNvSpPr/>
+          <p:nvPr/>
+        </p:nvSpPr>
+        <p:spPr>
+          <a:xfrm>
+            <a:off x="3017520" y="2377440"/>
+            <a:ext cx="1371600" cy="502920"/>
+          </a:xfrm>
+          <a:prstGeom prst="rect">
+            <a:avLst/>
+          </a:prstGeom>
+          <a:noFill/>
+          <a:ln/>
+        </p:spPr>
+        <p:txBody>
+          <a:bodyPr wrap="square" rtlCol="0" anchor="ctr"/>
+          <a:lstStyle/>
+          <a:p>
+            <a:pPr indent="0" marL="0">
+              <a:buNone/>
+            </a:pPr>
+            <a:r>
+              <a:rPr lang="en-US" sz="1100" dirty="0">
+                <a:solidFill>
+                  <a:srgbClr val="FFFFFF"/>
+                </a:solidFill>
+                <a:latin typeface="Consolas" pitchFamily="34" charset="0"/>
+                <a:ea typeface="Consolas" pitchFamily="34" charset="-122"/>
+                <a:cs typeface="Consolas" pitchFamily="34" charset="-120"/>
+              </a:rPr>
+              <a:t>#1E40AF</a:t>
+            </a:r>
+            <a:endParaRPr lang="en-US" sz="1100" dirty="0"/>
+          </a:p>
+        </p:txBody>
+      </p:sp>
+      <p:sp>
+        <p:nvSpPr>
+          <p:cNvPr id="14" name="Text 12"/>
+          <p:cNvSpPr/>
+          <p:nvPr/>
+        </p:nvSpPr>
+        <p:spPr>
+          <a:xfrm>
+            <a:off x="4572000" y="2377440"/>
+            <a:ext cx="3657600" cy="502920"/>
+          </a:xfrm>
+          <a:prstGeom prst="rect">
+            <a:avLst/>
+          </a:prstGeom>
+          <a:noFill/>
+          <a:ln/>
+        </p:spPr>
+        <p:txBody>
+          <a:bodyPr wrap="square" rtlCol="0" anchor="ctr"/>
+          <a:lstStyle/>
+          <a:p>
+            <a:pPr indent="0" marL="0">
+              <a:buNone/>
+            </a:pPr>
+            <a:r>
+              <a:rPr lang="en-US" sz="1100" dirty="0">
+                <a:solidFill>
+                  <a:srgbClr val="FFFFFF"/>
+                </a:solidFill>
+                <a:latin typeface="Arial" pitchFamily="34" charset="0"/>
+                <a:ea typeface="Arial" pitchFamily="34" charset="-122"/>
+                <a:cs typeface="Arial" pitchFamily="34" charset="-120"/>
+              </a:rPr>
+              <a:t>Gradiente azul</a:t>
+            </a:r>
+            <a:endParaRPr lang="en-US" sz="1100" dirty="0"/>
+          </a:p>
+        </p:txBody>
+      </p:sp>
+      <p:sp>
+        <p:nvSpPr>
+          <p:cNvPr id="15" name="Shape 13"/>
+          <p:cNvSpPr/>
+          <p:nvPr/>
+        </p:nvSpPr>
+        <p:spPr>
+          <a:xfrm>
+            <a:off x="457200" y="2971800"/>
+            <a:ext cx="8229600" cy="502920"/>
+          </a:xfrm>
+          <a:prstGeom prst="roundRect">
+            <a:avLst/>
+          </a:prstGeom>
+          <a:solidFill>
+            <a:srgbClr val="10B981"/>
+          </a:solidFill>
+          <a:ln w="6350">
+            <a:solidFill>
+              <a:srgbClr val="E2E8F0"/>
+            </a:solidFill>
+            <a:prstDash val="solid"/>
+          </a:ln>
+        </p:spPr>
+      </p:sp>
+      <p:sp>
+        <p:nvSpPr>
+          <p:cNvPr id="16" name="Text 14"/>
+          <p:cNvSpPr/>
+          <p:nvPr/>
+        </p:nvSpPr>
+        <p:spPr>
+          <a:xfrm>
+            <a:off x="640080" y="2971800"/>
+            <a:ext cx="2286000" cy="502920"/>
+          </a:xfrm>
+          <a:prstGeom prst="rect">
+            <a:avLst/>
+          </a:prstGeom>
+          <a:noFill/>
+          <a:ln/>
+        </p:spPr>
+        <p:txBody>
+          <a:bodyPr wrap="square" rtlCol="0" anchor="ctr"/>
+          <a:lstStyle/>
+          <a:p>
+            <a:pPr indent="0" marL="0">
+              <a:buNone/>
+            </a:pPr>
+            <a:r>
+              <a:rPr lang="en-US" sz="1200" b="1" dirty="0">
+                <a:solidFill>
+                  <a:srgbClr val="FFFFFF"/>
+                </a:solidFill>
+                <a:latin typeface="Arial" pitchFamily="34" charset="0"/>
+                <a:ea typeface="Arial" pitchFamily="34" charset="-122"/>
+                <a:cs typeface="Arial" pitchFamily="34" charset="-120"/>
+              </a:rPr>
+              <a:t>Success</a:t>
+            </a:r>
+            <a:endParaRPr lang="en-US" sz="1200" dirty="0"/>
+          </a:p>
+        </p:txBody>
+      </p:sp>
+      <p:sp>
+        <p:nvSpPr>
+          <p:cNvPr id="17" name="Text 15"/>
+          <p:cNvSpPr/>
+          <p:nvPr/>
+        </p:nvSpPr>
+        <p:spPr>
+          <a:xfrm>
+            <a:off x="3017520" y="2971800"/>
+            <a:ext cx="1371600" cy="502920"/>
+          </a:xfrm>
+          <a:prstGeom prst="rect">
+            <a:avLst/>
+          </a:prstGeom>
+          <a:noFill/>
+          <a:ln/>
+        </p:spPr>
+        <p:txBody>
+          <a:bodyPr wrap="square" rtlCol="0" anchor="ctr"/>
+          <a:lstStyle/>
+          <a:p>
+            <a:pPr indent="0" marL="0">
+              <a:buNone/>
+            </a:pPr>
+            <a:r>
+              <a:rPr lang="en-US" sz="1100" dirty="0">
+                <a:solidFill>
+                  <a:srgbClr val="FFFFFF"/>
+                </a:solidFill>
+                <a:latin typeface="Consolas" pitchFamily="34" charset="0"/>
+                <a:ea typeface="Consolas" pitchFamily="34" charset="-122"/>
+                <a:cs typeface="Consolas" pitchFamily="34" charset="-120"/>
+              </a:rPr>
+              <a:t>#10B981</a:t>
+            </a:r>
+            <a:endParaRPr lang="en-US" sz="1100" dirty="0"/>
+          </a:p>
+        </p:txBody>
+      </p:sp>
+      <p:sp>
+        <p:nvSpPr>
+          <p:cNvPr id="18" name="Text 16"/>
+          <p:cNvSpPr/>
+          <p:nvPr/>
+        </p:nvSpPr>
+        <p:spPr>
+          <a:xfrm>
+            <a:off x="4572000" y="2971800"/>
+            <a:ext cx="3657600" cy="502920"/>
+          </a:xfrm>
+          <a:prstGeom prst="rect">
+            <a:avLst/>
+          </a:prstGeom>
+          <a:noFill/>
+          <a:ln/>
+        </p:spPr>
+        <p:txBody>
+          <a:bodyPr wrap="square" rtlCol="0" anchor="ctr"/>
+          <a:lstStyle/>
+          <a:p>
+            <a:pPr indent="0" marL="0">
+              <a:buNone/>
+            </a:pPr>
+            <a:r>
+              <a:rPr lang="en-US" sz="1100" dirty="0">
+                <a:solidFill>
+                  <a:srgbClr val="FFFFFF"/>
+                </a:solidFill>
+                <a:latin typeface="Arial" pitchFamily="34" charset="0"/>
+                <a:ea typeface="Arial" pitchFamily="34" charset="-122"/>
+                <a:cs typeface="Arial" pitchFamily="34" charset="-120"/>
+              </a:rPr>
+              <a:t>Stock OK</a:t>
+            </a:r>
+            <a:endParaRPr lang="en-US" sz="1100" dirty="0"/>
+          </a:p>
+        </p:txBody>
+      </p:sp>
+      <p:sp>
+        <p:nvSpPr>
+          <p:cNvPr id="19" name="Shape 17"/>
+          <p:cNvSpPr/>
+          <p:nvPr/>
+        </p:nvSpPr>
+        <p:spPr>
+          <a:xfrm>
+            <a:off x="457200" y="3566160"/>
+            <a:ext cx="8229600" cy="502920"/>
+          </a:xfrm>
+          <a:prstGeom prst="roundRect">
+            <a:avLst/>
+          </a:prstGeom>
+          <a:solidFill>
+            <a:srgbClr val="F59E0B"/>
+          </a:solidFill>
+          <a:ln w="6350">
+            <a:solidFill>
+              <a:srgbClr val="E2E8F0"/>
+            </a:solidFill>
+            <a:prstDash val="solid"/>
+          </a:ln>
+        </p:spPr>
+      </p:sp>
+      <p:sp>
+        <p:nvSpPr>
+          <p:cNvPr id="20" name="Text 18"/>
+          <p:cNvSpPr/>
+          <p:nvPr/>
+        </p:nvSpPr>
+        <p:spPr>
+          <a:xfrm>
+            <a:off x="640080" y="3566160"/>
+            <a:ext cx="2286000" cy="502920"/>
+          </a:xfrm>
+          <a:prstGeom prst="rect">
+            <a:avLst/>
+          </a:prstGeom>
+          <a:noFill/>
+          <a:ln/>
+        </p:spPr>
+        <p:txBody>
+          <a:bodyPr wrap="square" rtlCol="0" anchor="ctr"/>
+          <a:lstStyle/>
+          <a:p>
+            <a:pPr indent="0" marL="0">
+              <a:buNone/>
+            </a:pPr>
+            <a:r>
+              <a:rPr lang="en-US" sz="1200" b="1" dirty="0">
+                <a:solidFill>
+                  <a:srgbClr val="FFFFFF"/>
+                </a:solidFill>
+                <a:latin typeface="Arial" pitchFamily="34" charset="0"/>
+                <a:ea typeface="Arial" pitchFamily="34" charset="-122"/>
+                <a:cs typeface="Arial" pitchFamily="34" charset="-120"/>
+              </a:rPr>
+              <a:t>Warning</a:t>
+            </a:r>
+            <a:endParaRPr lang="en-US" sz="1200" dirty="0"/>
+          </a:p>
+        </p:txBody>
+      </p:sp>
+      <p:sp>
+        <p:nvSpPr>
+          <p:cNvPr id="21" name="Text 19"/>
+          <p:cNvSpPr/>
+          <p:nvPr/>
+        </p:nvSpPr>
+        <p:spPr>
+          <a:xfrm>
+            <a:off x="3017520" y="3566160"/>
+            <a:ext cx="1371600" cy="502920"/>
+          </a:xfrm>
+          <a:prstGeom prst="rect">
+            <a:avLst/>
+          </a:prstGeom>
+          <a:noFill/>
+          <a:ln/>
+        </p:spPr>
+        <p:txBody>
+          <a:bodyPr wrap="square" rtlCol="0" anchor="ctr"/>
+          <a:lstStyle/>
+          <a:p>
+            <a:pPr indent="0" marL="0">
+              <a:buNone/>
+            </a:pPr>
+            <a:r>
+              <a:rPr lang="en-US" sz="1100" dirty="0">
+                <a:solidFill>
+                  <a:srgbClr val="FFFFFF"/>
+                </a:solidFill>
+                <a:latin typeface="Consolas" pitchFamily="34" charset="0"/>
+                <a:ea typeface="Consolas" pitchFamily="34" charset="-122"/>
+                <a:cs typeface="Consolas" pitchFamily="34" charset="-120"/>
+              </a:rPr>
+              <a:t>#F59E0B</a:t>
+            </a:r>
+            <a:endParaRPr lang="en-US" sz="1100" dirty="0"/>
+          </a:p>
+        </p:txBody>
+      </p:sp>
+      <p:sp>
+        <p:nvSpPr>
+          <p:cNvPr id="22" name="Text 20"/>
+          <p:cNvSpPr/>
+          <p:nvPr/>
+        </p:nvSpPr>
+        <p:spPr>
+          <a:xfrm>
+            <a:off x="4572000" y="3566160"/>
+            <a:ext cx="3657600" cy="502920"/>
+          </a:xfrm>
+          <a:prstGeom prst="rect">
+            <a:avLst/>
+          </a:prstGeom>
+          <a:noFill/>
+          <a:ln/>
+        </p:spPr>
+        <p:txBody>
+          <a:bodyPr wrap="square" rtlCol="0" anchor="ctr"/>
+          <a:lstStyle/>
+          <a:p>
+            <a:pPr indent="0" marL="0">
+              <a:buNone/>
+            </a:pPr>
+            <a:r>
+              <a:rPr lang="en-US" sz="1100" dirty="0">
+                <a:solidFill>
+                  <a:srgbClr val="FFFFFF"/>
+                </a:solidFill>
+                <a:latin typeface="Arial" pitchFamily="34" charset="0"/>
+                <a:ea typeface="Arial" pitchFamily="34" charset="-122"/>
+                <a:cs typeface="Arial" pitchFamily="34" charset="-120"/>
+              </a:rPr>
+              <a:t>Stock ajustado</a:t>
+            </a:r>
+            <a:endParaRPr lang="en-US" sz="1100" dirty="0"/>
+          </a:p>
+        </p:txBody>
+      </p:sp>
+      <p:sp>
+        <p:nvSpPr>
+          <p:cNvPr id="23" name="Shape 21"/>
+          <p:cNvSpPr/>
+          <p:nvPr/>
+        </p:nvSpPr>
+        <p:spPr>
+          <a:xfrm>
+            <a:off x="457200" y="4160520"/>
+            <a:ext cx="8229600" cy="502920"/>
+          </a:xfrm>
+          <a:prstGeom prst="roundRect">
+            <a:avLst/>
+          </a:prstGeom>
+          <a:solidFill>
+            <a:srgbClr val="EF4444"/>
+          </a:solidFill>
+          <a:ln w="6350">
+            <a:solidFill>
+              <a:srgbClr val="E2E8F0"/>
+            </a:solidFill>
+            <a:prstDash val="solid"/>
+          </a:ln>
+        </p:spPr>
+      </p:sp>
+      <p:sp>
+        <p:nvSpPr>
+          <p:cNvPr id="24" name="Text 22"/>
+          <p:cNvSpPr/>
+          <p:nvPr/>
+        </p:nvSpPr>
+        <p:spPr>
+          <a:xfrm>
+            <a:off x="640080" y="4160520"/>
+            <a:ext cx="2286000" cy="502920"/>
+          </a:xfrm>
+          <a:prstGeom prst="rect">
+            <a:avLst/>
+          </a:prstGeom>
+          <a:noFill/>
+          <a:ln/>
+        </p:spPr>
+        <p:txBody>
+          <a:bodyPr wrap="square" rtlCol="0" anchor="ctr"/>
+          <a:lstStyle/>
+          <a:p>
+            <a:pPr indent="0" marL="0">
+              <a:buNone/>
+            </a:pPr>
+            <a:r>
+              <a:rPr lang="en-US" sz="1200" b="1" dirty="0">
+                <a:solidFill>
+                  <a:srgbClr val="FFFFFF"/>
+                </a:solidFill>
+                <a:latin typeface="Arial" pitchFamily="34" charset="0"/>
+                <a:ea typeface="Arial" pitchFamily="34" charset="-122"/>
+                <a:cs typeface="Arial" pitchFamily="34" charset="-120"/>
+              </a:rPr>
+              <a:t>Error</a:t>
+            </a:r>
+            <a:endParaRPr lang="en-US" sz="1200" dirty="0"/>
+          </a:p>
+        </p:txBody>
+      </p:sp>
+      <p:sp>
+        <p:nvSpPr>
+          <p:cNvPr id="25" name="Text 23"/>
+          <p:cNvSpPr/>
+          <p:nvPr/>
+        </p:nvSpPr>
+        <p:spPr>
+          <a:xfrm>
+            <a:off x="3017520" y="4160520"/>
+            <a:ext cx="1371600" cy="502920"/>
+          </a:xfrm>
+          <a:prstGeom prst="rect">
+            <a:avLst/>
+          </a:prstGeom>
+          <a:noFill/>
+          <a:ln/>
+        </p:spPr>
+        <p:txBody>
+          <a:bodyPr wrap="square" rtlCol="0" anchor="ctr"/>
+          <a:lstStyle/>
+          <a:p>
+            <a:pPr indent="0" marL="0">
+              <a:buNone/>
+            </a:pPr>
+            <a:r>
+              <a:rPr lang="en-US" sz="1100" dirty="0">
+                <a:solidFill>
+                  <a:srgbClr val="FFFFFF"/>
+                </a:solidFill>
+                <a:latin typeface="Consolas" pitchFamily="34" charset="0"/>
+                <a:ea typeface="Consolas" pitchFamily="34" charset="-122"/>
+                <a:cs typeface="Consolas" pitchFamily="34" charset="-120"/>
+              </a:rPr>
+              <a:t>#EF4444</a:t>
+            </a:r>
+            <a:endParaRPr lang="en-US" sz="1100" dirty="0"/>
+          </a:p>
+        </p:txBody>
+      </p:sp>
+      <p:sp>
+        <p:nvSpPr>
+          <p:cNvPr id="26" name="Text 24"/>
+          <p:cNvSpPr/>
+          <p:nvPr/>
+        </p:nvSpPr>
+        <p:spPr>
+          <a:xfrm>
+            <a:off x="4572000" y="4160520"/>
+            <a:ext cx="3657600" cy="502920"/>
+          </a:xfrm>
+          <a:prstGeom prst="rect">
+            <a:avLst/>
+          </a:prstGeom>
+          <a:noFill/>
+          <a:ln/>
+        </p:spPr>
+        <p:txBody>
+          <a:bodyPr wrap="square" rtlCol="0" anchor="ctr"/>
+          <a:lstStyle/>
+          <a:p>
+            <a:pPr indent="0" marL="0">
+              <a:buNone/>
+            </a:pPr>
+            <a:r>
+              <a:rPr lang="en-US" sz="1100" dirty="0">
+                <a:solidFill>
+                  <a:srgbClr val="FFFFFF"/>
+                </a:solidFill>
+                <a:latin typeface="Arial" pitchFamily="34" charset="0"/>
+                <a:ea typeface="Arial" pitchFamily="34" charset="-122"/>
+                <a:cs typeface="Arial" pitchFamily="34" charset="-120"/>
+              </a:rPr>
+              <a:t>Agotado</a:t>
+            </a:r>
+            <a:endParaRPr lang="en-US" sz="1100" dirty="0"/>
+          </a:p>
+        </p:txBody>
+      </p:sp>
+    </p:spTree>
+  </p:cSld>
+  <p:clrMapOvr>
+    <a:masterClrMapping/>
+  </p:clrMapOvr>
+</p:sld>
+</file>
+
+<file path=ppt/slides/slide9.xml><?xml version="1.0" encoding="utf-8"?>
+<p:sld xmlns:a="http://schemas.openxmlformats.org/drawingml/2006/main" xmlns:r="http://schemas.openxmlformats.org/officeDocument/2006/relationships" xmlns:p="http://schemas.openxmlformats.org/presentationml/2006/main">
+  <p:cSld name="Slide 9">
     <p:bg>
       <p:bgPr>
         <a:solidFill>
@@ -4248,7 +5810,7 @@
             <a:r>
               <a:rPr lang="en-US" sz="1800" dirty="0">
                 <a:solidFill>
-                  <a:srgbClr val="00796B"/>
+                  <a:srgbClr val="2563EB"/>
                 </a:solidFill>
                 <a:latin typeface="Arial" pitchFamily="34" charset="0"/>
                 <a:ea typeface="Arial" pitchFamily="34" charset="-122"/>
@@ -4285,7 +5847,7 @@
               <a:buNone/>
             </a:pPr>
             <a:r>
-              <a:rPr lang="en-US" sz="1400" dirty="0">
+              <a:rPr lang="en-US" sz="1200" dirty="0">
                 <a:solidFill>
                   <a:srgbClr val="64748B"/>
                 </a:solidFill>
@@ -4293,9 +5855,9 @@
                 <a:ea typeface="Arial" pitchFamily="34" charset="-122"/>
                 <a:cs typeface="Arial" pitchFamily="34" charset="-120"/>
               </a:rPr>
-              <a:t>CIPSA OrderX v6.0.0</a:t>
-            </a:r>
-            <a:endParaRPr lang="en-US" sz="1400" dirty="0"/>
+              <a:t>CIPSA OrderX v6.0.0 — Paleta Azul Corporativa</a:t>
+            </a:r>
+            <a:endParaRPr lang="en-US" sz="1200" dirty="0"/>
           </a:p>
         </p:txBody>
       </p:sp>

</xml_diff>